<commit_message>
Add an English edition of the setup deck
Same 23 slides, same order, same numbers, written in English rather than
translated line by line.

Rather than copy the generator, the theme, the three layouts and the seven
drawing helpers move to deck_kit.js, which both editions build on. Each
build file now holds nothing but its own words, so a spacing or colour
change lands in one place and both editions keep looking like one set --
which two copies would not have managed for long.

Rebuilt the Thai edition on the shared kit first and checked it renders
identically, so the refactor is not carrying a change in with it.

The faults table needed its own sizing in English: the same rows wrap more
often and ran into the footer, so that table is a point smaller there.

Co-Authored-By: Claude Opus 5 (1M context) <noreply@anthropic.com>
</commit_message>
<xml_diff>
--- a/docs/Tiny-Robot-Setup-Guide-TH.pptx
+++ b/docs/Tiny-Robot-Setup-Guide-TH.pptx
@@ -129,7 +129,7 @@
   <p:extLst>
     <p:ext uri="{521415D9-36F7-43E2-AB2F-B90AF26B5E84}">
       <p14:sectionLst xmlns:p14="http://schemas.microsoft.com/office/powerpoint/2010/main">
-        <p14:section name="ภาพรวม" id="{dcc12fe2-db61-3415-c8d5-3e1a5905f846}">
+        <p14:section name="ภาพรวม" id="{cfb3adf3-770d-bdf2-8246-6952c2819416}">
           <p14:sldIdLst>
             <p14:sldId id="256"/>
             <p14:sldId id="257"/>
@@ -137,7 +137,7 @@
             <p14:sldId id="259"/>
           </p14:sldIdLst>
         </p14:section>
-        <p14:section name="ติดตั้ง" id="{220aae83-f0d2-28bc-b3dd-c3c13539b529}">
+        <p14:section name="ติดตั้ง" id="{32fe05de-509a-93e4-9c53-948b2ea4f8bd}">
           <p14:sldIdLst>
             <p14:sldId id="260"/>
             <p14:sldId id="261"/>
@@ -149,7 +149,7 @@
             <p14:sldId id="267"/>
           </p14:sldIdLst>
         </p14:section>
-        <p14:section name="ใช้งานจริง" id="{a7b8c6e9-7926-c1cf-0f45-2c5ab4cdaef0}">
+        <p14:section name="ใช้งานจริง" id="{3a39b87e-4b9e-c495-5c34-b3847d8d6241}">
           <p14:sldIdLst>
             <p14:sldId id="268"/>
             <p14:sldId id="269"/>
@@ -158,7 +158,7 @@
             <p14:sldId id="272"/>
           </p14:sldIdLst>
         </p14:section>
-        <p14:section name="ปรับแต่งและแก้ปัญหา" id="{f7ccbec8-38f1-b99a-1d37-3c94eaff4960}">
+        <p14:section name="ปรับแต่งและแก้ปัญหา" id="{678bfed0-21e2-334b-ceb4-b43b5df3c393}">
           <p14:sldIdLst>
             <p14:sldId id="273"/>
             <p14:sldId id="274"/>

</xml_diff>